<commit_message>
Minor updates to slides
</commit_message>
<xml_diff>
--- a/docs/northwind-kyc-slides.pptx
+++ b/docs/northwind-kyc-slides.pptx
@@ -5432,8 +5432,8 @@
         </p:nvSpPr>
         <p:spPr>
           <a:xfrm>
-            <a:off x="641300" y="1555402"/>
-            <a:ext cx="3463975" cy="1746197"/>
+            <a:off x="641300" y="1504958"/>
+            <a:ext cx="3463975" cy="1796642"/>
           </a:xfrm>
           <a:prstGeom prst="rect">
             <a:avLst/>
@@ -5450,7 +5450,7 @@
                 <a:spcPts val="1365"/>
               </a:lnSpc>
               <a:spcAft>
-                <a:spcPts val="600"/>
+                <a:spcPts val="500"/>
               </a:spcAft>
               <a:buSzPct val="100000"/>
               <a:buChar char="•"/>
@@ -5466,7 +5466,6 @@
               </a:rPr>
               <a:t>KYC check fails on attempts 1–2 (simulated transient error), passes on attempt 3</a:t>
             </a:r>
-            <a:endParaRPr lang="en-US" sz="1050" dirty="0"/>
           </a:p>
           <a:p>
             <a:pPr marL="88900" indent="-88900" algn="l">
@@ -5474,7 +5473,30 @@
                 <a:spcPts val="1365"/>
               </a:lnSpc>
               <a:spcAft>
-                <a:spcPts val="600"/>
+                <a:spcPts val="500"/>
+              </a:spcAft>
+              <a:buSzPct val="100000"/>
+              <a:buChar char="•"/>
+            </a:pPr>
+            <a:r>
+              <a:rPr lang="en-US" sz="1050" dirty="0">
+                <a:solidFill>
+                  <a:srgbClr val="2E4053"/>
+                </a:solidFill>
+                <a:latin typeface="Arial" pitchFamily="34" charset="0"/>
+                <a:cs typeface="Arial" pitchFamily="34" charset="-120"/>
+              </a:rPr>
+              <a:t>Workflow is resilient to infra failures</a:t>
+            </a:r>
+            <a:endParaRPr lang="en-US" sz="1050" dirty="0"/>
+          </a:p>
+          <a:p>
+            <a:pPr marL="88900" indent="-88900" algn="l">
+              <a:lnSpc>
+                <a:spcPts val="1365"/>
+              </a:lnSpc>
+              <a:spcAft>
+                <a:spcPts val="500"/>
               </a:spcAft>
               <a:buSzPct val="100000"/>
               <a:buChar char="•"/>
@@ -5498,7 +5520,7 @@
                 <a:spcPts val="1365"/>
               </a:lnSpc>
               <a:spcAft>
-                <a:spcPts val="600"/>
+                <a:spcPts val="500"/>
               </a:spcAft>
               <a:buSzPct val="100000"/>
               <a:buFontTx/>
@@ -5523,7 +5545,7 @@
                 <a:spcPts val="1365"/>
               </a:lnSpc>
               <a:spcAft>
-                <a:spcPts val="600"/>
+                <a:spcPts val="500"/>
               </a:spcAft>
               <a:buSzPct val="100000"/>
               <a:buChar char="•"/>
@@ -5546,7 +5568,7 @@
                 <a:spcPts val="1365"/>
               </a:lnSpc>
               <a:spcAft>
-                <a:spcPts val="600"/>
+                <a:spcPts val="500"/>
               </a:spcAft>
               <a:buSzPct val="100000"/>
               <a:buChar char="•"/>
@@ -5786,7 +5808,7 @@
                 <a:spcPts val="1365"/>
               </a:lnSpc>
               <a:spcAft>
-                <a:spcPts val="600"/>
+                <a:spcPts val="500"/>
               </a:spcAft>
               <a:buSzPct val="100000"/>
               <a:buChar char="•"/>
@@ -5802,7 +5824,6 @@
               </a:rPr>
               <a:t>KYC_FORCE_FAIL=true — vendor returns false, no exception, no retry</a:t>
             </a:r>
-            <a:endParaRPr lang="en-US" sz="1050" dirty="0"/>
           </a:p>
           <a:p>
             <a:pPr marL="88900" indent="-88900" algn="l">
@@ -5810,7 +5831,7 @@
                 <a:spcPts val="1365"/>
               </a:lnSpc>
               <a:spcAft>
-                <a:spcPts val="600"/>
+                <a:spcPts val="500"/>
               </a:spcAft>
               <a:buSzPct val="100000"/>
               <a:buChar char="•"/>
@@ -5821,10 +5842,9 @@
                   <a:srgbClr val="2E4053"/>
                 </a:solidFill>
                 <a:latin typeface="Arial" pitchFamily="34" charset="0"/>
-                <a:ea typeface="Arial" pitchFamily="34" charset="-122"/>
-                <a:cs typeface="Arial" pitchFamily="34" charset="-120"/>
-              </a:rPr>
-              <a:t>Workflow reads false and calls rejectApplication() immediately</a:t>
+                <a:cs typeface="Arial" pitchFamily="34" charset="-120"/>
+              </a:rPr>
+              <a:t>Workflow auto-rejected due to SLA breach (Timeout)</a:t>
             </a:r>
             <a:endParaRPr lang="en-US" sz="1050" dirty="0"/>
           </a:p>
@@ -5834,7 +5854,7 @@
                 <a:spcPts val="1365"/>
               </a:lnSpc>
               <a:spcAft>
-                <a:spcPts val="600"/>
+                <a:spcPts val="500"/>
               </a:spcAft>
               <a:buSzPct val="100000"/>
               <a:buChar char="•"/>
@@ -5848,7 +5868,7 @@
                 <a:ea typeface="Arial" pitchFamily="34" charset="-122"/>
                 <a:cs typeface="Arial" pitchFamily="34" charset="-120"/>
               </a:rPr>
-              <a:t>Clean terminal REJECTED state with an accurate audit trail</a:t>
+              <a:t>Workflow reads false and calls rejectApplication() immediately</a:t>
             </a:r>
             <a:endParaRPr lang="en-US" sz="1050" dirty="0"/>
           </a:p>
@@ -5858,7 +5878,31 @@
                 <a:spcPts val="1365"/>
               </a:lnSpc>
               <a:spcAft>
-                <a:spcPts val="600"/>
+                <a:spcPts val="500"/>
+              </a:spcAft>
+              <a:buSzPct val="100000"/>
+              <a:buChar char="•"/>
+            </a:pPr>
+            <a:r>
+              <a:rPr lang="en-US" sz="1050" dirty="0">
+                <a:solidFill>
+                  <a:srgbClr val="2E4053"/>
+                </a:solidFill>
+                <a:latin typeface="Arial" pitchFamily="34" charset="0"/>
+                <a:ea typeface="Arial" pitchFamily="34" charset="-122"/>
+                <a:cs typeface="Arial" pitchFamily="34" charset="-120"/>
+              </a:rPr>
+              <a:t>Clean terminal REJECTED state with an accurate audit trail</a:t>
+            </a:r>
+            <a:endParaRPr lang="en-US" sz="1050" dirty="0"/>
+          </a:p>
+          <a:p>
+            <a:pPr marL="88900" indent="-88900" algn="l">
+              <a:lnSpc>
+                <a:spcPts val="1365"/>
+              </a:lnSpc>
+              <a:spcAft>
+                <a:spcPts val="500"/>
               </a:spcAft>
               <a:buSzPct val="100000"/>
               <a:buChar char="•"/>

</xml_diff>